<commit_message>
Improved text on slides
</commit_message>
<xml_diff>
--- a/LectureSlides/06a_WhyInferenceIsImportant.pptx
+++ b/LectureSlides/06a_WhyInferenceIsImportant.pptx
@@ -5,7 +5,7 @@
     <p:sldMasterId id="2147483648" r:id="rId1"/>
   </p:sldMasterIdLst>
   <p:notesMasterIdLst>
-    <p:notesMasterId r:id="rId23"/>
+    <p:notesMasterId r:id="rId25"/>
   </p:notesMasterIdLst>
   <p:sldIdLst>
     <p:sldId id="299" r:id="rId2"/>
@@ -16,19 +16,21 @@
     <p:sldId id="300" r:id="rId7"/>
     <p:sldId id="265" r:id="rId8"/>
     <p:sldId id="266" r:id="rId9"/>
-    <p:sldId id="267" r:id="rId10"/>
-    <p:sldId id="301" r:id="rId11"/>
-    <p:sldId id="272" r:id="rId12"/>
-    <p:sldId id="268" r:id="rId13"/>
-    <p:sldId id="269" r:id="rId14"/>
-    <p:sldId id="270" r:id="rId15"/>
-    <p:sldId id="271" r:id="rId16"/>
-    <p:sldId id="275" r:id="rId17"/>
-    <p:sldId id="273" r:id="rId18"/>
-    <p:sldId id="274" r:id="rId19"/>
-    <p:sldId id="276" r:id="rId20"/>
-    <p:sldId id="277" r:id="rId21"/>
-    <p:sldId id="278" r:id="rId22"/>
+    <p:sldId id="302" r:id="rId10"/>
+    <p:sldId id="267" r:id="rId11"/>
+    <p:sldId id="301" r:id="rId12"/>
+    <p:sldId id="272" r:id="rId13"/>
+    <p:sldId id="268" r:id="rId14"/>
+    <p:sldId id="269" r:id="rId15"/>
+    <p:sldId id="270" r:id="rId16"/>
+    <p:sldId id="271" r:id="rId17"/>
+    <p:sldId id="303" r:id="rId18"/>
+    <p:sldId id="275" r:id="rId19"/>
+    <p:sldId id="273" r:id="rId20"/>
+    <p:sldId id="274" r:id="rId21"/>
+    <p:sldId id="276" r:id="rId22"/>
+    <p:sldId id="277" r:id="rId23"/>
+    <p:sldId id="278" r:id="rId24"/>
   </p:sldIdLst>
   <p:sldSz cx="9144000" cy="5143500" type="screen16x9"/>
   <p:notesSz cx="6858000" cy="9144000"/>
@@ -560,7 +562,7 @@
           <a:p>
             <a:fld id="{AF8CCC53-3991-4E99-A819-F5012985658F}" type="slidenum">
               <a:rPr lang="en-US" smtClean="0"/>
-              <a:t>10</a:t>
+              <a:t>11</a:t>
             </a:fld>
             <a:endParaRPr lang="en-US"/>
           </a:p>
@@ -648,7 +650,7 @@
           <a:p>
             <a:fld id="{AF8CCC53-3991-4E99-A819-F5012985658F}" type="slidenum">
               <a:rPr lang="en-US" smtClean="0"/>
-              <a:t>12</a:t>
+              <a:t>13</a:t>
             </a:fld>
             <a:endParaRPr lang="en-US"/>
           </a:p>
@@ -3799,6 +3801,483 @@
 </file>
 
 <file path=ppt/slides/slide10.xml><?xml version="1.0" encoding="utf-8"?>
+<p:sld xmlns:a="http://schemas.openxmlformats.org/drawingml/2006/main" xmlns:r="http://schemas.openxmlformats.org/officeDocument/2006/relationships" xmlns:p="http://schemas.openxmlformats.org/presentationml/2006/main">
+  <p:cSld>
+    <p:spTree>
+      <p:nvGrpSpPr>
+        <p:cNvPr id="1" name=""/>
+        <p:cNvGrpSpPr/>
+        <p:nvPr/>
+      </p:nvGrpSpPr>
+      <p:grpSpPr>
+        <a:xfrm>
+          <a:off x="0" y="0"/>
+          <a:ext cx="0" cy="0"/>
+          <a:chOff x="0" y="0"/>
+          <a:chExt cx="0" cy="0"/>
+        </a:xfrm>
+      </p:grpSpPr>
+      <p:sp>
+        <p:nvSpPr>
+          <p:cNvPr id="2" name="Title 1"/>
+          <p:cNvSpPr>
+            <a:spLocks noGrp="1"/>
+          </p:cNvSpPr>
+          <p:nvPr>
+            <p:ph type="title"/>
+          </p:nvPr>
+        </p:nvSpPr>
+        <p:spPr/>
+        <p:txBody>
+          <a:bodyPr/>
+          <a:lstStyle/>
+          <a:p>
+            <a:pPr marL="0" lvl="0" indent="0">
+              <a:buNone/>
+            </a:pPr>
+            <a:r>
+              <a:t>Confidence Intervals; the Key to Inference</a:t>
+            </a:r>
+          </a:p>
+        </p:txBody>
+      </p:sp>
+      <p:sp>
+        <p:nvSpPr>
+          <p:cNvPr id="3" name="Content Placeholder 2"/>
+          <p:cNvSpPr>
+            <a:spLocks noGrp="1"/>
+          </p:cNvSpPr>
+          <p:nvPr>
+            <p:ph idx="1"/>
+          </p:nvPr>
+        </p:nvSpPr>
+        <p:spPr>
+          <a:xfrm>
+            <a:off x="457200" y="1121229"/>
+            <a:ext cx="8229600" cy="3976914"/>
+          </a:xfrm>
+        </p:spPr>
+        <p:txBody>
+          <a:bodyPr>
+            <a:normAutofit fontScale="92500" lnSpcReduction="20000"/>
+          </a:bodyPr>
+          <a:lstStyle/>
+          <a:p>
+            <a:pPr marL="0" lvl="0" indent="0">
+              <a:buNone/>
+            </a:pPr>
+            <a:r>
+              <a:rPr dirty="0"/>
+              <a:t>In frequentist statistics uncertainty of an inference is expressed in terms of a </a:t>
+            </a:r>
+            <a:r>
+              <a:rPr b="1" dirty="0"/>
+              <a:t>confidence interval</a:t>
+            </a:r>
+          </a:p>
+          <a:p>
+            <a:pPr lvl="0"/>
+            <a:r>
+              <a:rPr dirty="0"/>
+              <a:t>A confidence interval is defined as the expected </a:t>
+            </a:r>
+            <a:r>
+              <a:rPr lang="en-US" dirty="0"/>
+              <a:t>variation</a:t>
+            </a:r>
+            <a:r>
+              <a:rPr dirty="0"/>
+              <a:t> of a statistical </a:t>
+            </a:r>
+            <a:r>
+              <a:rPr b="1" dirty="0"/>
+              <a:t>point estimate</a:t>
+            </a:r>
+            <a:r>
+              <a:rPr lang="en-US" dirty="0"/>
+              <a:t> from </a:t>
+            </a:r>
+            <a:r>
+              <a:rPr lang="en-US" b="1" dirty="0"/>
+              <a:t>random sampling alone</a:t>
+            </a:r>
+          </a:p>
+          <a:p>
+            <a:pPr lvl="1"/>
+            <a:r>
+              <a:rPr dirty="0"/>
+              <a:t>A </a:t>
+            </a:r>
+            <a:r>
+              <a:rPr b="1" dirty="0"/>
+              <a:t>point estimate</a:t>
+            </a:r>
+            <a:r>
+              <a:rPr dirty="0"/>
+              <a:t> is the best estimate of a statistic</a:t>
+            </a:r>
+            <a:r>
+              <a:rPr lang="en-US" dirty="0"/>
+              <a:t> from the sampled observations</a:t>
+            </a:r>
+            <a:endParaRPr dirty="0"/>
+          </a:p>
+          <a:p>
+            <a:pPr lvl="1"/>
+            <a:r>
+              <a:rPr lang="en-US" dirty="0"/>
+              <a:t>E</a:t>
+            </a:r>
+            <a:r>
+              <a:rPr dirty="0"/>
+              <a:t>xample, </a:t>
+            </a:r>
+            <a:r>
+              <a:rPr lang="en-US" dirty="0"/>
+              <a:t>a</a:t>
+            </a:r>
+            <a:r>
+              <a:rPr dirty="0"/>
+              <a:t> </a:t>
+            </a:r>
+            <a:r>
+              <a:rPr b="1" dirty="0"/>
+              <a:t>maximum likelihood estimate </a:t>
+            </a:r>
+            <a:r>
+              <a:rPr dirty="0"/>
+              <a:t>of a mode</a:t>
+            </a:r>
+            <a:r>
+              <a:rPr lang="en-US" dirty="0"/>
+              <a:t>l</a:t>
+            </a:r>
+            <a:r>
+              <a:rPr dirty="0"/>
+              <a:t> parameter given the </a:t>
+            </a:r>
+            <a:r>
+              <a:rPr lang="en-US" dirty="0"/>
+              <a:t>observations</a:t>
+            </a:r>
+            <a:endParaRPr dirty="0"/>
+          </a:p>
+          <a:p>
+            <a:pPr lvl="0"/>
+            <a:r>
+              <a:rPr dirty="0"/>
+              <a:t>Two types of </a:t>
+            </a:r>
+            <a:r>
+              <a:rPr dirty="0" err="1"/>
+              <a:t>of</a:t>
+            </a:r>
+            <a:r>
+              <a:rPr dirty="0"/>
+              <a:t> confidence intervals:</a:t>
+            </a:r>
+          </a:p>
+          <a:p>
+            <a:pPr lvl="1"/>
+            <a:r>
+              <a:rPr b="1" dirty="0"/>
+              <a:t>Two-sided confidence intervals:</a:t>
+            </a:r>
+            <a:r>
+              <a:rPr dirty="0"/>
+              <a:t> express confidence that a </a:t>
+            </a:r>
+            <a:r>
+              <a:rPr lang="en-US" dirty="0"/>
+              <a:t>sample estimate </a:t>
+            </a:r>
+            <a:r>
+              <a:rPr dirty="0"/>
+              <a:t>is within some range around the point estimate</a:t>
+            </a:r>
+          </a:p>
+          <a:p>
+            <a:pPr lvl="1"/>
+            <a:r>
+              <a:rPr b="1" dirty="0"/>
+              <a:t>One-sided confidence intervals:</a:t>
+            </a:r>
+            <a:r>
+              <a:rPr dirty="0"/>
+              <a:t> express confidence that the </a:t>
+            </a:r>
+            <a:r>
+              <a:rPr lang="en-US" dirty="0"/>
+              <a:t>sample</a:t>
+            </a:r>
+            <a:r>
+              <a:rPr dirty="0"/>
+              <a:t> estimate is greater or less than some range of values</a:t>
+            </a:r>
+          </a:p>
+        </p:txBody>
+      </p:sp>
+    </p:spTree>
+  </p:cSld>
+  <p:clrMapOvr>
+    <a:masterClrMapping/>
+  </p:clrMapOvr>
+  <p:timing>
+    <p:tnLst>
+      <p:par>
+        <p:cTn id="1" dur="indefinite" restart="never" nodeType="tmRoot">
+          <p:childTnLst>
+            <p:seq concurrent="1" nextAc="seek">
+              <p:cTn id="2" dur="indefinite" nodeType="mainSeq">
+                <p:childTnLst>
+                  <p:par>
+                    <p:cTn id="3" fill="hold">
+                      <p:stCondLst>
+                        <p:cond delay="indefinite"/>
+                      </p:stCondLst>
+                      <p:childTnLst>
+                        <p:par>
+                          <p:cTn id="4" fill="hold">
+                            <p:stCondLst>
+                              <p:cond delay="0"/>
+                            </p:stCondLst>
+                            <p:childTnLst>
+                              <p:par>
+                                <p:cTn id="5" presetID="1" presetClass="entr" presetSubtype="0" fill="hold" nodeType="clickEffect">
+                                  <p:stCondLst>
+                                    <p:cond delay="0"/>
+                                  </p:stCondLst>
+                                  <p:childTnLst>
+                                    <p:set>
+                                      <p:cBhvr>
+                                        <p:cTn id="6" dur="1" fill="hold">
+                                          <p:stCondLst>
+                                            <p:cond delay="0"/>
+                                          </p:stCondLst>
+                                        </p:cTn>
+                                        <p:tgtEl>
+                                          <p:spTgt spid="3">
+                                            <p:txEl>
+                                              <p:pRg st="1" end="1"/>
+                                            </p:txEl>
+                                          </p:spTgt>
+                                        </p:tgtEl>
+                                        <p:attrNameLst>
+                                          <p:attrName>style.visibility</p:attrName>
+                                        </p:attrNameLst>
+                                      </p:cBhvr>
+                                      <p:to>
+                                        <p:strVal val="visible"/>
+                                      </p:to>
+                                    </p:set>
+                                  </p:childTnLst>
+                                </p:cTn>
+                              </p:par>
+                              <p:par>
+                                <p:cTn id="7" presetID="1" presetClass="entr" presetSubtype="0" fill="hold" nodeType="withEffect">
+                                  <p:stCondLst>
+                                    <p:cond delay="0"/>
+                                  </p:stCondLst>
+                                  <p:childTnLst>
+                                    <p:set>
+                                      <p:cBhvr>
+                                        <p:cTn id="8" dur="1" fill="hold">
+                                          <p:stCondLst>
+                                            <p:cond delay="0"/>
+                                          </p:stCondLst>
+                                        </p:cTn>
+                                        <p:tgtEl>
+                                          <p:spTgt spid="3">
+                                            <p:txEl>
+                                              <p:pRg st="2" end="2"/>
+                                            </p:txEl>
+                                          </p:spTgt>
+                                        </p:tgtEl>
+                                        <p:attrNameLst>
+                                          <p:attrName>style.visibility</p:attrName>
+                                        </p:attrNameLst>
+                                      </p:cBhvr>
+                                      <p:to>
+                                        <p:strVal val="visible"/>
+                                      </p:to>
+                                    </p:set>
+                                  </p:childTnLst>
+                                </p:cTn>
+                              </p:par>
+                              <p:par>
+                                <p:cTn id="9" presetID="1" presetClass="entr" presetSubtype="0" fill="hold" nodeType="withEffect">
+                                  <p:stCondLst>
+                                    <p:cond delay="0"/>
+                                  </p:stCondLst>
+                                  <p:childTnLst>
+                                    <p:set>
+                                      <p:cBhvr>
+                                        <p:cTn id="10" dur="1" fill="hold">
+                                          <p:stCondLst>
+                                            <p:cond delay="0"/>
+                                          </p:stCondLst>
+                                        </p:cTn>
+                                        <p:tgtEl>
+                                          <p:spTgt spid="3">
+                                            <p:txEl>
+                                              <p:pRg st="3" end="3"/>
+                                            </p:txEl>
+                                          </p:spTgt>
+                                        </p:tgtEl>
+                                        <p:attrNameLst>
+                                          <p:attrName>style.visibility</p:attrName>
+                                        </p:attrNameLst>
+                                      </p:cBhvr>
+                                      <p:to>
+                                        <p:strVal val="visible"/>
+                                      </p:to>
+                                    </p:set>
+                                  </p:childTnLst>
+                                </p:cTn>
+                              </p:par>
+                            </p:childTnLst>
+                          </p:cTn>
+                        </p:par>
+                      </p:childTnLst>
+                    </p:cTn>
+                  </p:par>
+                  <p:par>
+                    <p:cTn id="11" fill="hold">
+                      <p:stCondLst>
+                        <p:cond delay="indefinite"/>
+                      </p:stCondLst>
+                      <p:childTnLst>
+                        <p:par>
+                          <p:cTn id="12" fill="hold">
+                            <p:stCondLst>
+                              <p:cond delay="0"/>
+                            </p:stCondLst>
+                            <p:childTnLst>
+                              <p:par>
+                                <p:cTn id="13" presetID="1" presetClass="entr" presetSubtype="0" fill="hold" nodeType="clickEffect">
+                                  <p:stCondLst>
+                                    <p:cond delay="0"/>
+                                  </p:stCondLst>
+                                  <p:childTnLst>
+                                    <p:set>
+                                      <p:cBhvr>
+                                        <p:cTn id="14" dur="1" fill="hold">
+                                          <p:stCondLst>
+                                            <p:cond delay="0"/>
+                                          </p:stCondLst>
+                                        </p:cTn>
+                                        <p:tgtEl>
+                                          <p:spTgt spid="3">
+                                            <p:txEl>
+                                              <p:pRg st="4" end="4"/>
+                                            </p:txEl>
+                                          </p:spTgt>
+                                        </p:tgtEl>
+                                        <p:attrNameLst>
+                                          <p:attrName>style.visibility</p:attrName>
+                                        </p:attrNameLst>
+                                      </p:cBhvr>
+                                      <p:to>
+                                        <p:strVal val="visible"/>
+                                      </p:to>
+                                    </p:set>
+                                  </p:childTnLst>
+                                </p:cTn>
+                              </p:par>
+                              <p:par>
+                                <p:cTn id="15" presetID="1" presetClass="entr" presetSubtype="0" fill="hold" nodeType="withEffect">
+                                  <p:stCondLst>
+                                    <p:cond delay="0"/>
+                                  </p:stCondLst>
+                                  <p:childTnLst>
+                                    <p:set>
+                                      <p:cBhvr>
+                                        <p:cTn id="16" dur="1" fill="hold">
+                                          <p:stCondLst>
+                                            <p:cond delay="0"/>
+                                          </p:stCondLst>
+                                        </p:cTn>
+                                        <p:tgtEl>
+                                          <p:spTgt spid="3">
+                                            <p:txEl>
+                                              <p:pRg st="5" end="5"/>
+                                            </p:txEl>
+                                          </p:spTgt>
+                                        </p:tgtEl>
+                                        <p:attrNameLst>
+                                          <p:attrName>style.visibility</p:attrName>
+                                        </p:attrNameLst>
+                                      </p:cBhvr>
+                                      <p:to>
+                                        <p:strVal val="visible"/>
+                                      </p:to>
+                                    </p:set>
+                                  </p:childTnLst>
+                                </p:cTn>
+                              </p:par>
+                              <p:par>
+                                <p:cTn id="17" presetID="1" presetClass="entr" presetSubtype="0" fill="hold" nodeType="withEffect">
+                                  <p:stCondLst>
+                                    <p:cond delay="0"/>
+                                  </p:stCondLst>
+                                  <p:childTnLst>
+                                    <p:set>
+                                      <p:cBhvr>
+                                        <p:cTn id="18" dur="1" fill="hold">
+                                          <p:stCondLst>
+                                            <p:cond delay="0"/>
+                                          </p:stCondLst>
+                                        </p:cTn>
+                                        <p:tgtEl>
+                                          <p:spTgt spid="3">
+                                            <p:txEl>
+                                              <p:pRg st="6" end="6"/>
+                                            </p:txEl>
+                                          </p:spTgt>
+                                        </p:tgtEl>
+                                        <p:attrNameLst>
+                                          <p:attrName>style.visibility</p:attrName>
+                                        </p:attrNameLst>
+                                      </p:cBhvr>
+                                      <p:to>
+                                        <p:strVal val="visible"/>
+                                      </p:to>
+                                    </p:set>
+                                  </p:childTnLst>
+                                </p:cTn>
+                              </p:par>
+                            </p:childTnLst>
+                          </p:cTn>
+                        </p:par>
+                      </p:childTnLst>
+                    </p:cTn>
+                  </p:par>
+                </p:childTnLst>
+              </p:cTn>
+              <p:prevCondLst>
+                <p:cond evt="onPrev" delay="0">
+                  <p:tgtEl>
+                    <p:sldTgt/>
+                  </p:tgtEl>
+                </p:cond>
+              </p:prevCondLst>
+              <p:nextCondLst>
+                <p:cond evt="onNext" delay="0">
+                  <p:tgtEl>
+                    <p:sldTgt/>
+                  </p:tgtEl>
+                </p:cond>
+              </p:nextCondLst>
+            </p:seq>
+          </p:childTnLst>
+        </p:cTn>
+      </p:par>
+    </p:tnLst>
+  </p:timing>
+</p:sld>
+</file>
+
+<file path=ppt/slides/slide11.xml><?xml version="1.0" encoding="utf-8"?>
 <p:sld xmlns:a="http://schemas.openxmlformats.org/drawingml/2006/main" xmlns:r="http://schemas.openxmlformats.org/officeDocument/2006/relationships" xmlns:p="http://schemas.openxmlformats.org/presentationml/2006/main">
   <p:cSld>
     <p:spTree>
@@ -4699,7 +5178,7 @@
 </p:sld>
 </file>
 
-<file path=ppt/slides/slide11.xml><?xml version="1.0" encoding="utf-8"?>
+<file path=ppt/slides/slide12.xml><?xml version="1.0" encoding="utf-8"?>
 <p:sld xmlns:a="http://schemas.openxmlformats.org/drawingml/2006/main" xmlns:r="http://schemas.openxmlformats.org/officeDocument/2006/relationships" xmlns:p="http://schemas.openxmlformats.org/presentationml/2006/main">
   <p:cSld>
     <p:spTree>
@@ -5705,7 +6184,7 @@
 </p:sld>
 </file>
 
-<file path=ppt/slides/slide12.xml><?xml version="1.0" encoding="utf-8"?>
+<file path=ppt/slides/slide13.xml><?xml version="1.0" encoding="utf-8"?>
 <p:sld xmlns:a="http://schemas.openxmlformats.org/drawingml/2006/main" xmlns:r="http://schemas.openxmlformats.org/officeDocument/2006/relationships" xmlns:p="http://schemas.openxmlformats.org/presentationml/2006/main">
   <p:cSld>
     <p:spTree>
@@ -6706,7 +7185,7 @@
 </p:sld>
 </file>
 
-<file path=ppt/slides/slide13.xml><?xml version="1.0" encoding="utf-8"?>
+<file path=ppt/slides/slide14.xml><?xml version="1.0" encoding="utf-8"?>
 <p:sld xmlns:a="http://schemas.openxmlformats.org/drawingml/2006/main" xmlns:r="http://schemas.openxmlformats.org/officeDocument/2006/relationships" xmlns:p="http://schemas.openxmlformats.org/presentationml/2006/main">
   <p:cSld>
     <p:spTree>
@@ -7737,7 +8216,7 @@
 </p:sld>
 </file>
 
-<file path=ppt/slides/slide14.xml><?xml version="1.0" encoding="utf-8"?>
+<file path=ppt/slides/slide15.xml><?xml version="1.0" encoding="utf-8"?>
 <p:sld xmlns:a="http://schemas.openxmlformats.org/drawingml/2006/main" xmlns:r="http://schemas.openxmlformats.org/officeDocument/2006/relationships" xmlns:p="http://schemas.openxmlformats.org/presentationml/2006/main">
   <p:cSld>
     <p:spTree>
@@ -8459,7 +8938,7 @@
 </p:sld>
 </file>
 
-<file path=ppt/slides/slide15.xml><?xml version="1.0" encoding="utf-8"?>
+<file path=ppt/slides/slide16.xml><?xml version="1.0" encoding="utf-8"?>
 <p:sld xmlns:a="http://schemas.openxmlformats.org/drawingml/2006/main" xmlns:r="http://schemas.openxmlformats.org/officeDocument/2006/relationships" xmlns:p="http://schemas.openxmlformats.org/presentationml/2006/main">
   <p:cSld>
     <p:spTree>
@@ -9306,7 +9785,74 @@
 </p:sld>
 </file>
 
-<file path=ppt/slides/slide16.xml><?xml version="1.0" encoding="utf-8"?>
+<file path=ppt/slides/slide17.xml><?xml version="1.0" encoding="utf-8"?>
+<p:sld xmlns:a="http://schemas.openxmlformats.org/drawingml/2006/main" xmlns:r="http://schemas.openxmlformats.org/officeDocument/2006/relationships" xmlns:p="http://schemas.openxmlformats.org/presentationml/2006/main">
+  <p:cSld>
+    <p:spTree>
+      <p:nvGrpSpPr>
+        <p:cNvPr id="1" name="">
+          <a:extLst>
+            <a:ext uri="{FF2B5EF4-FFF2-40B4-BE49-F238E27FC236}">
+              <a16:creationId xmlns:a16="http://schemas.microsoft.com/office/drawing/2014/main" id="{80F65802-655D-9291-6606-0A6D41AD4749}"/>
+            </a:ext>
+          </a:extLst>
+        </p:cNvPr>
+        <p:cNvGrpSpPr/>
+        <p:nvPr/>
+      </p:nvGrpSpPr>
+      <p:grpSpPr>
+        <a:xfrm>
+          <a:off x="0" y="0"/>
+          <a:ext cx="0" cy="0"/>
+          <a:chOff x="0" y="0"/>
+          <a:chExt cx="0" cy="0"/>
+        </a:xfrm>
+      </p:grpSpPr>
+      <p:sp>
+        <p:nvSpPr>
+          <p:cNvPr id="3" name="Text Placeholder 2">
+            <a:extLst>
+              <a:ext uri="{FF2B5EF4-FFF2-40B4-BE49-F238E27FC236}">
+                <a16:creationId xmlns:a16="http://schemas.microsoft.com/office/drawing/2014/main" id="{D4724DE2-91E9-1BAD-4B59-6EA0DA0B2C88}"/>
+              </a:ext>
+            </a:extLst>
+          </p:cNvPr>
+          <p:cNvSpPr>
+            <a:spLocks noGrp="1"/>
+          </p:cNvSpPr>
+          <p:nvPr>
+            <p:ph type="body" idx="1"/>
+          </p:nvPr>
+        </p:nvSpPr>
+        <p:spPr/>
+        <p:txBody>
+          <a:bodyPr>
+            <a:normAutofit/>
+          </a:bodyPr>
+          <a:lstStyle/>
+          <a:p>
+            <a:pPr algn="ctr"/>
+            <a:r>
+              <a:rPr lang="en-US" sz="3200" dirty="0"/>
+              <a:t>Hypothesis Testing</a:t>
+            </a:r>
+          </a:p>
+        </p:txBody>
+      </p:sp>
+    </p:spTree>
+    <p:extLst>
+      <p:ext uri="{BB962C8B-B14F-4D97-AF65-F5344CB8AC3E}">
+        <p14:creationId xmlns:p14="http://schemas.microsoft.com/office/powerpoint/2010/main" val="1986237675"/>
+      </p:ext>
+    </p:extLst>
+  </p:cSld>
+  <p:clrMapOvr>
+    <a:masterClrMapping/>
+  </p:clrMapOvr>
+</p:sld>
+</file>
+
+<file path=ppt/slides/slide18.xml><?xml version="1.0" encoding="utf-8"?>
 <p:sld xmlns:a="http://schemas.openxmlformats.org/drawingml/2006/main" xmlns:r="http://schemas.openxmlformats.org/officeDocument/2006/relationships" xmlns:p="http://schemas.openxmlformats.org/presentationml/2006/main">
   <p:cSld>
     <p:spTree>
@@ -9936,7 +10482,7 @@
 </p:sld>
 </file>
 
-<file path=ppt/slides/slide17.xml><?xml version="1.0" encoding="utf-8"?>
+<file path=ppt/slides/slide19.xml><?xml version="1.0" encoding="utf-8"?>
 <p:sld xmlns:a="http://schemas.openxmlformats.org/drawingml/2006/main" xmlns:r="http://schemas.openxmlformats.org/officeDocument/2006/relationships" xmlns:p="http://schemas.openxmlformats.org/presentationml/2006/main">
   <p:cSld>
     <p:spTree>
@@ -10435,7 +10981,312 @@
 </p:sld>
 </file>
 
-<file path=ppt/slides/slide18.xml><?xml version="1.0" encoding="utf-8"?>
+<file path=ppt/slides/slide2.xml><?xml version="1.0" encoding="utf-8"?>
+<p:sld xmlns:a="http://schemas.openxmlformats.org/drawingml/2006/main" xmlns:r="http://schemas.openxmlformats.org/officeDocument/2006/relationships" xmlns:p="http://schemas.openxmlformats.org/presentationml/2006/main">
+  <p:cSld>
+    <p:spTree>
+      <p:nvGrpSpPr>
+        <p:cNvPr id="1" name=""/>
+        <p:cNvGrpSpPr/>
+        <p:nvPr/>
+      </p:nvGrpSpPr>
+      <p:grpSpPr>
+        <a:xfrm>
+          <a:off x="0" y="0"/>
+          <a:ext cx="0" cy="0"/>
+          <a:chOff x="0" y="0"/>
+          <a:chExt cx="0" cy="0"/>
+        </a:xfrm>
+      </p:grpSpPr>
+      <p:sp>
+        <p:nvSpPr>
+          <p:cNvPr id="2" name="Title 1"/>
+          <p:cNvSpPr>
+            <a:spLocks noGrp="1"/>
+          </p:cNvSpPr>
+          <p:nvPr>
+            <p:ph type="title"/>
+          </p:nvPr>
+        </p:nvSpPr>
+        <p:spPr/>
+        <p:txBody>
+          <a:bodyPr/>
+          <a:lstStyle/>
+          <a:p>
+            <a:pPr marL="0" lvl="0" indent="0">
+              <a:buNone/>
+            </a:pPr>
+            <a:r>
+              <a:rPr dirty="0"/>
+              <a:t>Introduction to Statistical Inference</a:t>
+            </a:r>
+          </a:p>
+        </p:txBody>
+      </p:sp>
+      <p:sp>
+        <p:nvSpPr>
+          <p:cNvPr id="3" name="Content Placeholder 2"/>
+          <p:cNvSpPr>
+            <a:spLocks noGrp="1"/>
+          </p:cNvSpPr>
+          <p:nvPr>
+            <p:ph idx="1"/>
+          </p:nvPr>
+        </p:nvSpPr>
+        <p:spPr/>
+        <p:txBody>
+          <a:bodyPr/>
+          <a:lstStyle/>
+          <a:p>
+            <a:pPr marL="0" lvl="0" indent="0">
+              <a:buNone/>
+            </a:pPr>
+            <a:r>
+              <a:rPr dirty="0"/>
+              <a:t>All statistical inference has uncertainty</a:t>
+            </a:r>
+          </a:p>
+          <a:p>
+            <a:pPr lvl="0"/>
+            <a:r>
+              <a:rPr dirty="0"/>
+              <a:t>Characterization of uncertainty is a goal of statistical inference</a:t>
+            </a:r>
+          </a:p>
+          <a:p>
+            <a:pPr lvl="1"/>
+            <a:r>
+              <a:rPr dirty="0"/>
+              <a:t>Any model using real-world data has inherent uncertainty</a:t>
+            </a:r>
+            <a:endParaRPr lang="en-US" dirty="0"/>
+          </a:p>
+          <a:p>
+            <a:pPr lvl="1"/>
+            <a:r>
+              <a:rPr lang="en-US" dirty="0"/>
+              <a:t>Quantification of uncertainty is vital to trustworthy inference </a:t>
+            </a:r>
+            <a:endParaRPr dirty="0"/>
+          </a:p>
+          <a:p>
+            <a:pPr lvl="0"/>
+            <a:r>
+              <a:rPr dirty="0"/>
+              <a:t>Statistical inference seeks to avoid being </a:t>
+            </a:r>
+            <a:r>
+              <a:rPr b="1" dirty="0">
+                <a:hlinkClick r:id="rId2"/>
+              </a:rPr>
+              <a:t>fooled by randomness</a:t>
+            </a:r>
+            <a:r>
+              <a:rPr dirty="0"/>
+              <a:t>; A catchy title of a book</a:t>
+            </a:r>
+          </a:p>
+        </p:txBody>
+      </p:sp>
+    </p:spTree>
+  </p:cSld>
+  <p:clrMapOvr>
+    <a:masterClrMapping/>
+  </p:clrMapOvr>
+  <p:timing>
+    <p:tnLst>
+      <p:par>
+        <p:cTn id="1" dur="indefinite" restart="never" nodeType="tmRoot">
+          <p:childTnLst>
+            <p:seq concurrent="1" nextAc="seek">
+              <p:cTn id="2" dur="indefinite" nodeType="mainSeq">
+                <p:childTnLst>
+                  <p:par>
+                    <p:cTn id="3" fill="hold">
+                      <p:stCondLst>
+                        <p:cond delay="indefinite"/>
+                      </p:stCondLst>
+                      <p:childTnLst>
+                        <p:par>
+                          <p:cTn id="4" fill="hold">
+                            <p:stCondLst>
+                              <p:cond delay="0"/>
+                            </p:stCondLst>
+                            <p:childTnLst>
+                              <p:par>
+                                <p:cTn id="5" presetID="1" presetClass="entr" presetSubtype="0" fill="hold" nodeType="clickEffect">
+                                  <p:stCondLst>
+                                    <p:cond delay="0"/>
+                                  </p:stCondLst>
+                                  <p:childTnLst>
+                                    <p:set>
+                                      <p:cBhvr>
+                                        <p:cTn id="6" dur="1" fill="hold">
+                                          <p:stCondLst>
+                                            <p:cond delay="0"/>
+                                          </p:stCondLst>
+                                        </p:cTn>
+                                        <p:tgtEl>
+                                          <p:spTgt spid="3">
+                                            <p:txEl>
+                                              <p:pRg st="1" end="1"/>
+                                            </p:txEl>
+                                          </p:spTgt>
+                                        </p:tgtEl>
+                                        <p:attrNameLst>
+                                          <p:attrName>style.visibility</p:attrName>
+                                        </p:attrNameLst>
+                                      </p:cBhvr>
+                                      <p:to>
+                                        <p:strVal val="visible"/>
+                                      </p:to>
+                                    </p:set>
+                                  </p:childTnLst>
+                                </p:cTn>
+                              </p:par>
+                              <p:par>
+                                <p:cTn id="7" presetID="1" presetClass="entr" presetSubtype="0" fill="hold" nodeType="withEffect">
+                                  <p:stCondLst>
+                                    <p:cond delay="0"/>
+                                  </p:stCondLst>
+                                  <p:childTnLst>
+                                    <p:set>
+                                      <p:cBhvr>
+                                        <p:cTn id="8" dur="1" fill="hold">
+                                          <p:stCondLst>
+                                            <p:cond delay="0"/>
+                                          </p:stCondLst>
+                                        </p:cTn>
+                                        <p:tgtEl>
+                                          <p:spTgt spid="3">
+                                            <p:txEl>
+                                              <p:pRg st="2" end="2"/>
+                                            </p:txEl>
+                                          </p:spTgt>
+                                        </p:tgtEl>
+                                        <p:attrNameLst>
+                                          <p:attrName>style.visibility</p:attrName>
+                                        </p:attrNameLst>
+                                      </p:cBhvr>
+                                      <p:to>
+                                        <p:strVal val="visible"/>
+                                      </p:to>
+                                    </p:set>
+                                  </p:childTnLst>
+                                </p:cTn>
+                              </p:par>
+                              <p:par>
+                                <p:cTn id="9" presetID="1" presetClass="entr" presetSubtype="0" fill="hold" nodeType="withEffect">
+                                  <p:stCondLst>
+                                    <p:cond delay="0"/>
+                                  </p:stCondLst>
+                                  <p:childTnLst>
+                                    <p:set>
+                                      <p:cBhvr>
+                                        <p:cTn id="10" dur="1" fill="hold">
+                                          <p:stCondLst>
+                                            <p:cond delay="0"/>
+                                          </p:stCondLst>
+                                        </p:cTn>
+                                        <p:tgtEl>
+                                          <p:spTgt spid="3">
+                                            <p:txEl>
+                                              <p:pRg st="3" end="3"/>
+                                            </p:txEl>
+                                          </p:spTgt>
+                                        </p:tgtEl>
+                                        <p:attrNameLst>
+                                          <p:attrName>style.visibility</p:attrName>
+                                        </p:attrNameLst>
+                                      </p:cBhvr>
+                                      <p:to>
+                                        <p:strVal val="visible"/>
+                                      </p:to>
+                                    </p:set>
+                                  </p:childTnLst>
+                                </p:cTn>
+                              </p:par>
+                            </p:childTnLst>
+                          </p:cTn>
+                        </p:par>
+                      </p:childTnLst>
+                    </p:cTn>
+                  </p:par>
+                  <p:par>
+                    <p:cTn id="11" fill="hold">
+                      <p:stCondLst>
+                        <p:cond delay="indefinite"/>
+                      </p:stCondLst>
+                      <p:childTnLst>
+                        <p:par>
+                          <p:cTn id="12" fill="hold">
+                            <p:stCondLst>
+                              <p:cond delay="0"/>
+                            </p:stCondLst>
+                            <p:childTnLst>
+                              <p:par>
+                                <p:cTn id="13" presetID="1" presetClass="entr" presetSubtype="0" fill="hold" nodeType="clickEffect">
+                                  <p:stCondLst>
+                                    <p:cond delay="0"/>
+                                  </p:stCondLst>
+                                  <p:childTnLst>
+                                    <p:set>
+                                      <p:cBhvr>
+                                        <p:cTn id="14" dur="1" fill="hold">
+                                          <p:stCondLst>
+                                            <p:cond delay="0"/>
+                                          </p:stCondLst>
+                                        </p:cTn>
+                                        <p:tgtEl>
+                                          <p:spTgt spid="3">
+                                            <p:txEl>
+                                              <p:pRg st="4" end="4"/>
+                                            </p:txEl>
+                                          </p:spTgt>
+                                        </p:tgtEl>
+                                        <p:attrNameLst>
+                                          <p:attrName>style.visibility</p:attrName>
+                                        </p:attrNameLst>
+                                      </p:cBhvr>
+                                      <p:to>
+                                        <p:strVal val="visible"/>
+                                      </p:to>
+                                    </p:set>
+                                  </p:childTnLst>
+                                </p:cTn>
+                              </p:par>
+                            </p:childTnLst>
+                          </p:cTn>
+                        </p:par>
+                      </p:childTnLst>
+                    </p:cTn>
+                  </p:par>
+                </p:childTnLst>
+              </p:cTn>
+              <p:prevCondLst>
+                <p:cond evt="onPrev" delay="0">
+                  <p:tgtEl>
+                    <p:sldTgt/>
+                  </p:tgtEl>
+                </p:cond>
+              </p:prevCondLst>
+              <p:nextCondLst>
+                <p:cond evt="onNext" delay="0">
+                  <p:tgtEl>
+                    <p:sldTgt/>
+                  </p:tgtEl>
+                </p:cond>
+              </p:nextCondLst>
+            </p:seq>
+          </p:childTnLst>
+        </p:cTn>
+      </p:par>
+    </p:tnLst>
+  </p:timing>
+</p:sld>
+</file>
+
+<file path=ppt/slides/slide20.xml><?xml version="1.0" encoding="utf-8"?>
 <p:sld xmlns:a="http://schemas.openxmlformats.org/drawingml/2006/main" xmlns:r="http://schemas.openxmlformats.org/officeDocument/2006/relationships" xmlns:p="http://schemas.openxmlformats.org/presentationml/2006/main">
   <p:cSld>
     <p:spTree>
@@ -10844,7 +11695,7 @@
 </p:sld>
 </file>
 
-<file path=ppt/slides/slide19.xml><?xml version="1.0" encoding="utf-8"?>
+<file path=ppt/slides/slide21.xml><?xml version="1.0" encoding="utf-8"?>
 <p:sld xmlns:a="http://schemas.openxmlformats.org/drawingml/2006/main" xmlns:r="http://schemas.openxmlformats.org/officeDocument/2006/relationships" xmlns:p="http://schemas.openxmlformats.org/presentationml/2006/main">
   <p:cSld>
     <p:spTree>
@@ -11312,7 +12163,7 @@
 </p:sld>
 </file>
 
-<file path=ppt/slides/slide2.xml><?xml version="1.0" encoding="utf-8"?>
+<file path=ppt/slides/slide22.xml><?xml version="1.0" encoding="utf-8"?>
 <p:sld xmlns:a="http://schemas.openxmlformats.org/drawingml/2006/main" xmlns:r="http://schemas.openxmlformats.org/officeDocument/2006/relationships" xmlns:p="http://schemas.openxmlformats.org/presentationml/2006/main">
   <p:cSld>
     <p:spTree>
@@ -11348,318 +12199,13 @@
               <a:buNone/>
             </a:pPr>
             <a:r>
-              <a:rPr dirty="0"/>
-              <a:t>Introduction to Statistical Inference</a:t>
+              <a:t>The P-Value</a:t>
             </a:r>
           </a:p>
         </p:txBody>
       </p:sp>
-      <p:sp>
-        <p:nvSpPr>
-          <p:cNvPr id="3" name="Content Placeholder 2"/>
-          <p:cNvSpPr>
-            <a:spLocks noGrp="1"/>
-          </p:cNvSpPr>
-          <p:nvPr>
-            <p:ph idx="1"/>
-          </p:nvPr>
-        </p:nvSpPr>
-        <p:spPr/>
-        <p:txBody>
-          <a:bodyPr/>
-          <a:lstStyle/>
-          <a:p>
-            <a:pPr marL="0" lvl="0" indent="0">
-              <a:buNone/>
-            </a:pPr>
-            <a:r>
-              <a:rPr dirty="0"/>
-              <a:t>All statistical inference has uncertainty</a:t>
-            </a:r>
-          </a:p>
-          <a:p>
-            <a:pPr lvl="0"/>
-            <a:r>
-              <a:rPr dirty="0"/>
-              <a:t>Characterization of uncertainty is a goal of statistical inference</a:t>
-            </a:r>
-          </a:p>
-          <a:p>
-            <a:pPr lvl="1"/>
-            <a:r>
-              <a:rPr dirty="0"/>
-              <a:t>Any model using real-world data has inherent uncertainty</a:t>
-            </a:r>
-            <a:endParaRPr lang="en-US" dirty="0"/>
-          </a:p>
-          <a:p>
-            <a:pPr lvl="1"/>
-            <a:r>
-              <a:rPr lang="en-US" dirty="0"/>
-              <a:t>Quantification of uncertainty is vital to trustworthy inference </a:t>
-            </a:r>
-            <a:endParaRPr dirty="0"/>
-          </a:p>
-          <a:p>
-            <a:pPr lvl="0"/>
-            <a:r>
-              <a:rPr dirty="0"/>
-              <a:t>Statistical inference seeks to avoid being </a:t>
-            </a:r>
-            <a:r>
-              <a:rPr b="1" dirty="0">
-                <a:hlinkClick r:id="rId2"/>
-              </a:rPr>
-              <a:t>fooled by randomness</a:t>
-            </a:r>
-            <a:r>
-              <a:rPr dirty="0"/>
-              <a:t>; A catchy title of a book</a:t>
-            </a:r>
-          </a:p>
-        </p:txBody>
-      </p:sp>
-    </p:spTree>
-  </p:cSld>
-  <p:clrMapOvr>
-    <a:masterClrMapping/>
-  </p:clrMapOvr>
-  <p:timing>
-    <p:tnLst>
-      <p:par>
-        <p:cTn id="1" dur="indefinite" restart="never" nodeType="tmRoot">
-          <p:childTnLst>
-            <p:seq concurrent="1" nextAc="seek">
-              <p:cTn id="2" dur="indefinite" nodeType="mainSeq">
-                <p:childTnLst>
-                  <p:par>
-                    <p:cTn id="3" fill="hold">
-                      <p:stCondLst>
-                        <p:cond delay="indefinite"/>
-                      </p:stCondLst>
-                      <p:childTnLst>
-                        <p:par>
-                          <p:cTn id="4" fill="hold">
-                            <p:stCondLst>
-                              <p:cond delay="0"/>
-                            </p:stCondLst>
-                            <p:childTnLst>
-                              <p:par>
-                                <p:cTn id="5" presetID="1" presetClass="entr" presetSubtype="0" fill="hold" nodeType="clickEffect">
-                                  <p:stCondLst>
-                                    <p:cond delay="0"/>
-                                  </p:stCondLst>
-                                  <p:childTnLst>
-                                    <p:set>
-                                      <p:cBhvr>
-                                        <p:cTn id="6" dur="1" fill="hold">
-                                          <p:stCondLst>
-                                            <p:cond delay="0"/>
-                                          </p:stCondLst>
-                                        </p:cTn>
-                                        <p:tgtEl>
-                                          <p:spTgt spid="3">
-                                            <p:txEl>
-                                              <p:pRg st="1" end="1"/>
-                                            </p:txEl>
-                                          </p:spTgt>
-                                        </p:tgtEl>
-                                        <p:attrNameLst>
-                                          <p:attrName>style.visibility</p:attrName>
-                                        </p:attrNameLst>
-                                      </p:cBhvr>
-                                      <p:to>
-                                        <p:strVal val="visible"/>
-                                      </p:to>
-                                    </p:set>
-                                  </p:childTnLst>
-                                </p:cTn>
-                              </p:par>
-                              <p:par>
-                                <p:cTn id="7" presetID="1" presetClass="entr" presetSubtype="0" fill="hold" nodeType="withEffect">
-                                  <p:stCondLst>
-                                    <p:cond delay="0"/>
-                                  </p:stCondLst>
-                                  <p:childTnLst>
-                                    <p:set>
-                                      <p:cBhvr>
-                                        <p:cTn id="8" dur="1" fill="hold">
-                                          <p:stCondLst>
-                                            <p:cond delay="0"/>
-                                          </p:stCondLst>
-                                        </p:cTn>
-                                        <p:tgtEl>
-                                          <p:spTgt spid="3">
-                                            <p:txEl>
-                                              <p:pRg st="2" end="2"/>
-                                            </p:txEl>
-                                          </p:spTgt>
-                                        </p:tgtEl>
-                                        <p:attrNameLst>
-                                          <p:attrName>style.visibility</p:attrName>
-                                        </p:attrNameLst>
-                                      </p:cBhvr>
-                                      <p:to>
-                                        <p:strVal val="visible"/>
-                                      </p:to>
-                                    </p:set>
-                                  </p:childTnLst>
-                                </p:cTn>
-                              </p:par>
-                              <p:par>
-                                <p:cTn id="9" presetID="1" presetClass="entr" presetSubtype="0" fill="hold" nodeType="withEffect">
-                                  <p:stCondLst>
-                                    <p:cond delay="0"/>
-                                  </p:stCondLst>
-                                  <p:childTnLst>
-                                    <p:set>
-                                      <p:cBhvr>
-                                        <p:cTn id="10" dur="1" fill="hold">
-                                          <p:stCondLst>
-                                            <p:cond delay="0"/>
-                                          </p:stCondLst>
-                                        </p:cTn>
-                                        <p:tgtEl>
-                                          <p:spTgt spid="3">
-                                            <p:txEl>
-                                              <p:pRg st="3" end="3"/>
-                                            </p:txEl>
-                                          </p:spTgt>
-                                        </p:tgtEl>
-                                        <p:attrNameLst>
-                                          <p:attrName>style.visibility</p:attrName>
-                                        </p:attrNameLst>
-                                      </p:cBhvr>
-                                      <p:to>
-                                        <p:strVal val="visible"/>
-                                      </p:to>
-                                    </p:set>
-                                  </p:childTnLst>
-                                </p:cTn>
-                              </p:par>
-                            </p:childTnLst>
-                          </p:cTn>
-                        </p:par>
-                      </p:childTnLst>
-                    </p:cTn>
-                  </p:par>
-                  <p:par>
-                    <p:cTn id="11" fill="hold">
-                      <p:stCondLst>
-                        <p:cond delay="indefinite"/>
-                      </p:stCondLst>
-                      <p:childTnLst>
-                        <p:par>
-                          <p:cTn id="12" fill="hold">
-                            <p:stCondLst>
-                              <p:cond delay="0"/>
-                            </p:stCondLst>
-                            <p:childTnLst>
-                              <p:par>
-                                <p:cTn id="13" presetID="1" presetClass="entr" presetSubtype="0" fill="hold" nodeType="clickEffect">
-                                  <p:stCondLst>
-                                    <p:cond delay="0"/>
-                                  </p:stCondLst>
-                                  <p:childTnLst>
-                                    <p:set>
-                                      <p:cBhvr>
-                                        <p:cTn id="14" dur="1" fill="hold">
-                                          <p:stCondLst>
-                                            <p:cond delay="0"/>
-                                          </p:stCondLst>
-                                        </p:cTn>
-                                        <p:tgtEl>
-                                          <p:spTgt spid="3">
-                                            <p:txEl>
-                                              <p:pRg st="4" end="4"/>
-                                            </p:txEl>
-                                          </p:spTgt>
-                                        </p:tgtEl>
-                                        <p:attrNameLst>
-                                          <p:attrName>style.visibility</p:attrName>
-                                        </p:attrNameLst>
-                                      </p:cBhvr>
-                                      <p:to>
-                                        <p:strVal val="visible"/>
-                                      </p:to>
-                                    </p:set>
-                                  </p:childTnLst>
-                                </p:cTn>
-                              </p:par>
-                            </p:childTnLst>
-                          </p:cTn>
-                        </p:par>
-                      </p:childTnLst>
-                    </p:cTn>
-                  </p:par>
-                </p:childTnLst>
-              </p:cTn>
-              <p:prevCondLst>
-                <p:cond evt="onPrev" delay="0">
-                  <p:tgtEl>
-                    <p:sldTgt/>
-                  </p:tgtEl>
-                </p:cond>
-              </p:prevCondLst>
-              <p:nextCondLst>
-                <p:cond evt="onNext" delay="0">
-                  <p:tgtEl>
-                    <p:sldTgt/>
-                  </p:tgtEl>
-                </p:cond>
-              </p:nextCondLst>
-            </p:seq>
-          </p:childTnLst>
-        </p:cTn>
-      </p:par>
-    </p:tnLst>
-  </p:timing>
-</p:sld>
-</file>
-
-<file path=ppt/slides/slide20.xml><?xml version="1.0" encoding="utf-8"?>
-<p:sld xmlns:a="http://schemas.openxmlformats.org/drawingml/2006/main" xmlns:r="http://schemas.openxmlformats.org/officeDocument/2006/relationships" xmlns:p="http://schemas.openxmlformats.org/presentationml/2006/main">
-  <p:cSld>
-    <p:spTree>
-      <p:nvGrpSpPr>
-        <p:cNvPr id="1" name=""/>
-        <p:cNvGrpSpPr/>
-        <p:nvPr/>
-      </p:nvGrpSpPr>
-      <p:grpSpPr>
-        <a:xfrm>
-          <a:off x="0" y="0"/>
-          <a:ext cx="0" cy="0"/>
-          <a:chOff x="0" y="0"/>
-          <a:chExt cx="0" cy="0"/>
-        </a:xfrm>
-      </p:grpSpPr>
-      <p:sp>
-        <p:nvSpPr>
-          <p:cNvPr id="2" name="Title 1"/>
-          <p:cNvSpPr>
-            <a:spLocks noGrp="1"/>
-          </p:cNvSpPr>
-          <p:nvPr>
-            <p:ph type="title"/>
-          </p:nvPr>
-        </p:nvSpPr>
-        <p:spPr/>
-        <p:txBody>
-          <a:bodyPr/>
-          <a:lstStyle/>
-          <a:p>
-            <a:pPr marL="0" lvl="0" indent="0">
-              <a:buNone/>
-            </a:pPr>
-            <a:r>
-              <a:t>The P-Value</a:t>
-            </a:r>
-          </a:p>
-        </p:txBody>
-      </p:sp>
-      <mc:AlternateContent xmlns:mc="http://schemas.openxmlformats.org/markup-compatibility/2006" xmlns:a14="http://schemas.microsoft.com/office/drawing/2010/main">
-        <mc:Choice Requires="a14">
+      <mc:AlternateContent xmlns:mc="http://schemas.openxmlformats.org/markup-compatibility/2006">
+        <mc:Choice xmlns:a14="http://schemas.microsoft.com/office/drawing/2010/main" Requires="a14">
           <p:sp>
             <p:nvSpPr>
               <p:cNvPr id="3" name="Content Placeholder 2"/>
@@ -11734,7 +12280,7 @@
               <a:p>
                 <a:pPr lvl="0"/>
                 <a:r>
-                  <a:rPr lang="en-US" b="1" dirty="0"/>
+                  <a:rPr lang="en-US" dirty="0"/>
                   <a:t>D</a:t>
                 </a:r>
                 <a:r>
@@ -11958,7 +12504,7 @@
             </p:txBody>
           </p:sp>
         </mc:Choice>
-        <mc:Fallback xmlns="">
+        <mc:Fallback>
           <p:sp>
             <p:nvSpPr>
               <p:cNvPr id="3" name="Content Placeholder 2"/>
@@ -12323,7 +12869,7 @@
 </p:sld>
 </file>
 
-<file path=ppt/slides/slide21.xml><?xml version="1.0" encoding="utf-8"?>
+<file path=ppt/slides/slide23.xml><?xml version="1.0" encoding="utf-8"?>
 <p:sld xmlns:a="http://schemas.openxmlformats.org/drawingml/2006/main" xmlns:r="http://schemas.openxmlformats.org/officeDocument/2006/relationships" xmlns:p="http://schemas.openxmlformats.org/presentationml/2006/main">
   <p:cSld>
     <p:spTree>
@@ -12519,14 +13065,14 @@
             <p:ph idx="1"/>
             <p:extLst>
               <p:ext uri="{D42A27DB-BD31-4B8C-83A1-F6EECF244321}">
-                <p14:modId xmlns:p14="http://schemas.microsoft.com/office/powerpoint/2010/main" val="1795092637"/>
+                <p14:modId xmlns:p14="http://schemas.microsoft.com/office/powerpoint/2010/main" val="1711332399"/>
               </p:ext>
             </p:extLst>
           </p:nvPr>
         </p:nvGraphicFramePr>
         <p:xfrm>
-          <a:off x="522514" y="1716213"/>
-          <a:ext cx="8331200" cy="3378940"/>
+          <a:off x="522514" y="1799730"/>
+          <a:ext cx="8331200" cy="2978706"/>
         </p:xfrm>
         <a:graphic>
           <a:graphicData uri="http://schemas.openxmlformats.org/drawingml/2006/table">
@@ -12628,7 +13174,7 @@
                   </a:ext>
                 </a:extLst>
               </a:tr>
-              <a:tr h="818620">
+              <a:tr h="654481">
                 <a:tc>
                   <a:txBody>
                     <a:bodyPr/>
@@ -12638,8 +13184,12 @@
                         <a:buNone/>
                       </a:pPr>
                       <a:r>
-                        <a:rPr sz="1800"/>
-                        <a:t>How much confidence should we have that a marketing campaign increased sales?</a:t>
+                        <a:rPr lang="en-US" sz="1800" dirty="0"/>
+                        <a:t>Did the latest </a:t>
+                      </a:r>
+                      <a:r>
+                        <a:rPr sz="1800" dirty="0"/>
+                        <a:t>marketing campaign increased sales?</a:t>
                       </a:r>
                     </a:p>
                   </a:txBody>
@@ -12667,7 +13217,7 @@
                   </a:ext>
                 </a:extLst>
               </a:tr>
-              <a:tr h="818620">
+              <a:tr h="678305">
                 <a:tc>
                   <a:txBody>
                     <a:bodyPr/>
@@ -12733,14 +13283,10 @@
                       </a:pPr>
                       <a:r>
                         <a:rPr sz="1800" dirty="0"/>
-                        <a:t>The model has made accurate predictions </a:t>
+                        <a:t>The model has made accurate predictions so far</a:t>
                       </a:r>
                       <a:r>
-                        <a:rPr sz="1800"/>
-                        <a:t>so far</a:t>
-                      </a:r>
-                      <a:r>
-                        <a:rPr lang="en-US" sz="1800"/>
+                        <a:rPr lang="en-US" sz="1800" dirty="0"/>
                         <a:t>….</a:t>
                       </a:r>
                       <a:endParaRPr sz="1800" dirty="0"/>
@@ -14570,7 +15116,23 @@
             <a:pPr lvl="0"/>
             <a:r>
               <a:rPr dirty="0"/>
-              <a:t>Statistical significance must not be confused importance to the problem being addressed!</a:t>
+              <a:t>Statistical significance must not be confused </a:t>
+            </a:r>
+            <a:r>
+              <a:rPr lang="en-US" dirty="0"/>
+              <a:t>with </a:t>
+            </a:r>
+            <a:r>
+              <a:rPr dirty="0"/>
+              <a:t>importance </a:t>
+            </a:r>
+            <a:r>
+              <a:rPr lang="en-US" dirty="0"/>
+              <a:t>for</a:t>
+            </a:r>
+            <a:r>
+              <a:rPr dirty="0"/>
+              <a:t> the problem being addressed!</a:t>
             </a:r>
             <a:endParaRPr lang="en-US" dirty="0"/>
           </a:p>
@@ -15134,461 +15696,45 @@
       </p:grpSpPr>
       <p:sp>
         <p:nvSpPr>
-          <p:cNvPr id="2" name="Title 1"/>
+          <p:cNvPr id="3" name="Text Placeholder 2">
+            <a:extLst>
+              <a:ext uri="{FF2B5EF4-FFF2-40B4-BE49-F238E27FC236}">
+                <a16:creationId xmlns:a16="http://schemas.microsoft.com/office/drawing/2014/main" id="{AA41574F-0B0C-7AE8-882D-CBE480D8D64D}"/>
+              </a:ext>
+            </a:extLst>
+          </p:cNvPr>
           <p:cNvSpPr>
             <a:spLocks noGrp="1"/>
           </p:cNvSpPr>
           <p:nvPr>
-            <p:ph type="title"/>
+            <p:ph type="body" idx="1"/>
           </p:nvPr>
         </p:nvSpPr>
         <p:spPr/>
         <p:txBody>
-          <a:bodyPr/>
-          <a:lstStyle/>
-          <a:p>
-            <a:pPr marL="0" lvl="0" indent="0">
-              <a:buNone/>
-            </a:pPr>
-            <a:r>
-              <a:t>Confidence Intervals; the Key to Inference</a:t>
-            </a:r>
-          </a:p>
-        </p:txBody>
-      </p:sp>
-      <p:sp>
-        <p:nvSpPr>
-          <p:cNvPr id="3" name="Content Placeholder 2"/>
-          <p:cNvSpPr>
-            <a:spLocks noGrp="1"/>
-          </p:cNvSpPr>
-          <p:nvPr>
-            <p:ph idx="1"/>
-          </p:nvPr>
-        </p:nvSpPr>
-        <p:spPr>
-          <a:xfrm>
-            <a:off x="457200" y="1121229"/>
-            <a:ext cx="8229600" cy="3976914"/>
-          </a:xfrm>
-        </p:spPr>
-        <p:txBody>
           <a:bodyPr>
-            <a:normAutofit fontScale="92500" lnSpcReduction="20000"/>
+            <a:normAutofit/>
           </a:bodyPr>
           <a:lstStyle/>
           <a:p>
-            <a:pPr marL="0" lvl="0" indent="0">
-              <a:buNone/>
-            </a:pPr>
-            <a:r>
-              <a:rPr dirty="0"/>
-              <a:t>In frequentist statistics uncertainty of an inference is expressed in terms of a </a:t>
-            </a:r>
-            <a:r>
-              <a:rPr b="1" dirty="0"/>
-              <a:t>confidence interval</a:t>
-            </a:r>
-          </a:p>
-          <a:p>
-            <a:pPr lvl="0"/>
-            <a:r>
-              <a:rPr dirty="0"/>
-              <a:t>A confidence interval is defined as the expected </a:t>
-            </a:r>
-            <a:r>
-              <a:rPr lang="en-US" dirty="0"/>
-              <a:t>variation</a:t>
-            </a:r>
-            <a:r>
-              <a:rPr dirty="0"/>
-              <a:t> of a statistical </a:t>
-            </a:r>
-            <a:r>
-              <a:rPr b="1" dirty="0"/>
-              <a:t>point estimate</a:t>
-            </a:r>
-            <a:r>
-              <a:rPr lang="en-US" dirty="0"/>
-              <a:t> from </a:t>
-            </a:r>
-            <a:r>
-              <a:rPr lang="en-US" b="1" dirty="0"/>
-              <a:t>random sampling alone</a:t>
-            </a:r>
-          </a:p>
-          <a:p>
-            <a:pPr lvl="1"/>
-            <a:r>
-              <a:rPr dirty="0"/>
-              <a:t>A </a:t>
-            </a:r>
-            <a:r>
-              <a:rPr b="1" dirty="0"/>
-              <a:t>point estimate</a:t>
-            </a:r>
-            <a:r>
-              <a:rPr dirty="0"/>
-              <a:t> is the best estimate of a statistic</a:t>
-            </a:r>
-            <a:r>
-              <a:rPr lang="en-US" dirty="0"/>
-              <a:t> from the sampled observations</a:t>
-            </a:r>
-            <a:endParaRPr dirty="0"/>
-          </a:p>
-          <a:p>
-            <a:pPr lvl="1"/>
-            <a:r>
-              <a:rPr lang="en-US" dirty="0"/>
-              <a:t>E</a:t>
-            </a:r>
-            <a:r>
-              <a:rPr dirty="0"/>
-              <a:t>xample, </a:t>
-            </a:r>
-            <a:r>
-              <a:rPr lang="en-US" dirty="0"/>
-              <a:t>a</a:t>
-            </a:r>
-            <a:r>
-              <a:rPr dirty="0"/>
-              <a:t> </a:t>
-            </a:r>
-            <a:r>
-              <a:rPr b="1" dirty="0"/>
-              <a:t>maximum likelihood estimate </a:t>
-            </a:r>
-            <a:r>
-              <a:rPr dirty="0"/>
-              <a:t>of a mode</a:t>
-            </a:r>
-            <a:r>
-              <a:rPr lang="en-US" dirty="0"/>
-              <a:t>l</a:t>
-            </a:r>
-            <a:r>
-              <a:rPr dirty="0"/>
-              <a:t> parameter given the </a:t>
-            </a:r>
-            <a:r>
-              <a:rPr lang="en-US" dirty="0"/>
-              <a:t>observations</a:t>
-            </a:r>
-            <a:endParaRPr dirty="0"/>
-          </a:p>
-          <a:p>
-            <a:pPr lvl="0"/>
-            <a:r>
-              <a:rPr dirty="0"/>
-              <a:t>Two types of </a:t>
-            </a:r>
-            <a:r>
-              <a:rPr dirty="0" err="1"/>
-              <a:t>of</a:t>
-            </a:r>
-            <a:r>
-              <a:rPr dirty="0"/>
-              <a:t> confidence intervals:</a:t>
-            </a:r>
-          </a:p>
-          <a:p>
-            <a:pPr lvl="1"/>
-            <a:r>
-              <a:rPr b="1" dirty="0"/>
-              <a:t>Two-sided confidence intervals:</a:t>
-            </a:r>
-            <a:r>
-              <a:rPr dirty="0"/>
-              <a:t> express confidence that a </a:t>
-            </a:r>
-            <a:r>
-              <a:rPr lang="en-US" dirty="0"/>
-              <a:t>sample estimate </a:t>
-            </a:r>
-            <a:r>
-              <a:rPr dirty="0"/>
-              <a:t>is within some range around the point estimate</a:t>
-            </a:r>
-          </a:p>
-          <a:p>
-            <a:pPr lvl="1"/>
-            <a:r>
-              <a:rPr b="1" dirty="0"/>
-              <a:t>One-sided confidence intervals:</a:t>
-            </a:r>
-            <a:r>
-              <a:rPr dirty="0"/>
-              <a:t> express confidence that the </a:t>
-            </a:r>
-            <a:r>
-              <a:rPr lang="en-US" dirty="0"/>
-              <a:t>sample</a:t>
-            </a:r>
-            <a:r>
-              <a:rPr dirty="0"/>
-              <a:t> estimate is greater or less than some range of values</a:t>
+            <a:pPr algn="ctr"/>
+            <a:r>
+              <a:rPr lang="en-US" sz="3200" dirty="0"/>
+              <a:t>Confidence Intervals</a:t>
             </a:r>
           </a:p>
         </p:txBody>
       </p:sp>
     </p:spTree>
+    <p:extLst>
+      <p:ext uri="{BB962C8B-B14F-4D97-AF65-F5344CB8AC3E}">
+        <p14:creationId xmlns:p14="http://schemas.microsoft.com/office/powerpoint/2010/main" val="3491666326"/>
+      </p:ext>
+    </p:extLst>
   </p:cSld>
   <p:clrMapOvr>
     <a:masterClrMapping/>
   </p:clrMapOvr>
-  <p:timing>
-    <p:tnLst>
-      <p:par>
-        <p:cTn id="1" dur="indefinite" restart="never" nodeType="tmRoot">
-          <p:childTnLst>
-            <p:seq concurrent="1" nextAc="seek">
-              <p:cTn id="2" dur="indefinite" nodeType="mainSeq">
-                <p:childTnLst>
-                  <p:par>
-                    <p:cTn id="3" fill="hold">
-                      <p:stCondLst>
-                        <p:cond delay="indefinite"/>
-                      </p:stCondLst>
-                      <p:childTnLst>
-                        <p:par>
-                          <p:cTn id="4" fill="hold">
-                            <p:stCondLst>
-                              <p:cond delay="0"/>
-                            </p:stCondLst>
-                            <p:childTnLst>
-                              <p:par>
-                                <p:cTn id="5" presetID="1" presetClass="entr" presetSubtype="0" fill="hold" nodeType="clickEffect">
-                                  <p:stCondLst>
-                                    <p:cond delay="0"/>
-                                  </p:stCondLst>
-                                  <p:childTnLst>
-                                    <p:set>
-                                      <p:cBhvr>
-                                        <p:cTn id="6" dur="1" fill="hold">
-                                          <p:stCondLst>
-                                            <p:cond delay="0"/>
-                                          </p:stCondLst>
-                                        </p:cTn>
-                                        <p:tgtEl>
-                                          <p:spTgt spid="3">
-                                            <p:txEl>
-                                              <p:pRg st="1" end="1"/>
-                                            </p:txEl>
-                                          </p:spTgt>
-                                        </p:tgtEl>
-                                        <p:attrNameLst>
-                                          <p:attrName>style.visibility</p:attrName>
-                                        </p:attrNameLst>
-                                      </p:cBhvr>
-                                      <p:to>
-                                        <p:strVal val="visible"/>
-                                      </p:to>
-                                    </p:set>
-                                  </p:childTnLst>
-                                </p:cTn>
-                              </p:par>
-                              <p:par>
-                                <p:cTn id="7" presetID="1" presetClass="entr" presetSubtype="0" fill="hold" nodeType="withEffect">
-                                  <p:stCondLst>
-                                    <p:cond delay="0"/>
-                                  </p:stCondLst>
-                                  <p:childTnLst>
-                                    <p:set>
-                                      <p:cBhvr>
-                                        <p:cTn id="8" dur="1" fill="hold">
-                                          <p:stCondLst>
-                                            <p:cond delay="0"/>
-                                          </p:stCondLst>
-                                        </p:cTn>
-                                        <p:tgtEl>
-                                          <p:spTgt spid="3">
-                                            <p:txEl>
-                                              <p:pRg st="2" end="2"/>
-                                            </p:txEl>
-                                          </p:spTgt>
-                                        </p:tgtEl>
-                                        <p:attrNameLst>
-                                          <p:attrName>style.visibility</p:attrName>
-                                        </p:attrNameLst>
-                                      </p:cBhvr>
-                                      <p:to>
-                                        <p:strVal val="visible"/>
-                                      </p:to>
-                                    </p:set>
-                                  </p:childTnLst>
-                                </p:cTn>
-                              </p:par>
-                              <p:par>
-                                <p:cTn id="9" presetID="1" presetClass="entr" presetSubtype="0" fill="hold" nodeType="withEffect">
-                                  <p:stCondLst>
-                                    <p:cond delay="0"/>
-                                  </p:stCondLst>
-                                  <p:childTnLst>
-                                    <p:set>
-                                      <p:cBhvr>
-                                        <p:cTn id="10" dur="1" fill="hold">
-                                          <p:stCondLst>
-                                            <p:cond delay="0"/>
-                                          </p:stCondLst>
-                                        </p:cTn>
-                                        <p:tgtEl>
-                                          <p:spTgt spid="3">
-                                            <p:txEl>
-                                              <p:pRg st="3" end="3"/>
-                                            </p:txEl>
-                                          </p:spTgt>
-                                        </p:tgtEl>
-                                        <p:attrNameLst>
-                                          <p:attrName>style.visibility</p:attrName>
-                                        </p:attrNameLst>
-                                      </p:cBhvr>
-                                      <p:to>
-                                        <p:strVal val="visible"/>
-                                      </p:to>
-                                    </p:set>
-                                  </p:childTnLst>
-                                </p:cTn>
-                              </p:par>
-                            </p:childTnLst>
-                          </p:cTn>
-                        </p:par>
-                      </p:childTnLst>
-                    </p:cTn>
-                  </p:par>
-                  <p:par>
-                    <p:cTn id="11" fill="hold">
-                      <p:stCondLst>
-                        <p:cond delay="indefinite"/>
-                      </p:stCondLst>
-                      <p:childTnLst>
-                        <p:par>
-                          <p:cTn id="12" fill="hold">
-                            <p:stCondLst>
-                              <p:cond delay="0"/>
-                            </p:stCondLst>
-                            <p:childTnLst>
-                              <p:par>
-                                <p:cTn id="13" presetID="1" presetClass="entr" presetSubtype="0" fill="hold" nodeType="clickEffect">
-                                  <p:stCondLst>
-                                    <p:cond delay="0"/>
-                                  </p:stCondLst>
-                                  <p:childTnLst>
-                                    <p:set>
-                                      <p:cBhvr>
-                                        <p:cTn id="14" dur="1" fill="hold">
-                                          <p:stCondLst>
-                                            <p:cond delay="0"/>
-                                          </p:stCondLst>
-                                        </p:cTn>
-                                        <p:tgtEl>
-                                          <p:spTgt spid="3">
-                                            <p:txEl>
-                                              <p:pRg st="4" end="4"/>
-                                            </p:txEl>
-                                          </p:spTgt>
-                                        </p:tgtEl>
-                                        <p:attrNameLst>
-                                          <p:attrName>style.visibility</p:attrName>
-                                        </p:attrNameLst>
-                                      </p:cBhvr>
-                                      <p:to>
-                                        <p:strVal val="visible"/>
-                                      </p:to>
-                                    </p:set>
-                                  </p:childTnLst>
-                                </p:cTn>
-                              </p:par>
-                              <p:par>
-                                <p:cTn id="15" presetID="1" presetClass="entr" presetSubtype="0" fill="hold" nodeType="withEffect">
-                                  <p:stCondLst>
-                                    <p:cond delay="0"/>
-                                  </p:stCondLst>
-                                  <p:childTnLst>
-                                    <p:set>
-                                      <p:cBhvr>
-                                        <p:cTn id="16" dur="1" fill="hold">
-                                          <p:stCondLst>
-                                            <p:cond delay="0"/>
-                                          </p:stCondLst>
-                                        </p:cTn>
-                                        <p:tgtEl>
-                                          <p:spTgt spid="3">
-                                            <p:txEl>
-                                              <p:pRg st="5" end="5"/>
-                                            </p:txEl>
-                                          </p:spTgt>
-                                        </p:tgtEl>
-                                        <p:attrNameLst>
-                                          <p:attrName>style.visibility</p:attrName>
-                                        </p:attrNameLst>
-                                      </p:cBhvr>
-                                      <p:to>
-                                        <p:strVal val="visible"/>
-                                      </p:to>
-                                    </p:set>
-                                  </p:childTnLst>
-                                </p:cTn>
-                              </p:par>
-                              <p:par>
-                                <p:cTn id="17" presetID="1" presetClass="entr" presetSubtype="0" fill="hold" nodeType="withEffect">
-                                  <p:stCondLst>
-                                    <p:cond delay="0"/>
-                                  </p:stCondLst>
-                                  <p:childTnLst>
-                                    <p:set>
-                                      <p:cBhvr>
-                                        <p:cTn id="18" dur="1" fill="hold">
-                                          <p:stCondLst>
-                                            <p:cond delay="0"/>
-                                          </p:stCondLst>
-                                        </p:cTn>
-                                        <p:tgtEl>
-                                          <p:spTgt spid="3">
-                                            <p:txEl>
-                                              <p:pRg st="6" end="6"/>
-                                            </p:txEl>
-                                          </p:spTgt>
-                                        </p:tgtEl>
-                                        <p:attrNameLst>
-                                          <p:attrName>style.visibility</p:attrName>
-                                        </p:attrNameLst>
-                                      </p:cBhvr>
-                                      <p:to>
-                                        <p:strVal val="visible"/>
-                                      </p:to>
-                                    </p:set>
-                                  </p:childTnLst>
-                                </p:cTn>
-                              </p:par>
-                            </p:childTnLst>
-                          </p:cTn>
-                        </p:par>
-                      </p:childTnLst>
-                    </p:cTn>
-                  </p:par>
-                </p:childTnLst>
-              </p:cTn>
-              <p:prevCondLst>
-                <p:cond evt="onPrev" delay="0">
-                  <p:tgtEl>
-                    <p:sldTgt/>
-                  </p:tgtEl>
-                </p:cond>
-              </p:prevCondLst>
-              <p:nextCondLst>
-                <p:cond evt="onNext" delay="0">
-                  <p:tgtEl>
-                    <p:sldTgt/>
-                  </p:tgtEl>
-                </p:cond>
-              </p:nextCondLst>
-            </p:seq>
-          </p:childTnLst>
-        </p:cTn>
-      </p:par>
-    </p:tnLst>
-  </p:timing>
 </p:sld>
 </file>
 

</xml_diff>

<commit_message>
Typo corrections from lectures
</commit_message>
<xml_diff>
--- a/LectureSlides/06a_WhyInferenceIsImportant.pptx
+++ b/LectureSlides/06a_WhyInferenceIsImportant.pptx
@@ -6225,8 +6225,8 @@
           </a:p>
         </p:txBody>
       </p:sp>
-      <mc:AlternateContent xmlns:mc="http://schemas.openxmlformats.org/markup-compatibility/2006" xmlns:a14="http://schemas.microsoft.com/office/drawing/2010/main">
-        <mc:Choice Requires="a14">
+      <mc:AlternateContent xmlns:mc="http://schemas.openxmlformats.org/markup-compatibility/2006">
+        <mc:Choice xmlns:a14="http://schemas.microsoft.com/office/drawing/2010/main" Requires="a14">
           <p:sp>
             <p:nvSpPr>
               <p:cNvPr id="3" name="Content Placeholder 2"/>
@@ -6270,7 +6270,7 @@
                 </a:r>
                 <a:r>
                   <a:rPr lang="en-US" dirty="0"/>
-                  <a:t>by as the range of the distribution with </a:t>
+                  <a:t>by as the range of the sampling distribution with </a:t>
                 </a:r>
                 <a14:m>
                   <m:oMath xmlns:m="http://schemas.openxmlformats.org/officeDocument/2006/math">
@@ -6448,7 +6448,7 @@
                 </a14:m>
                 <a:r>
                   <a:rPr lang="en-US" dirty="0"/>
-                  <a:t> quantiles of a distribution</a:t>
+                  <a:t> quantiles of a sampling distribution</a:t>
                 </a:r>
               </a:p>
               <a:p>
@@ -6869,7 +6869,7 @@
             </p:txBody>
           </p:sp>
         </mc:Choice>
-        <mc:Fallback xmlns="">
+        <mc:Fallback>
           <p:sp>
             <p:nvSpPr>
               <p:cNvPr id="3" name="Content Placeholder 2"/>
@@ -7226,8 +7226,8 @@
           </a:p>
         </p:txBody>
       </p:sp>
-      <mc:AlternateContent xmlns:mc="http://schemas.openxmlformats.org/markup-compatibility/2006" xmlns:a14="http://schemas.microsoft.com/office/drawing/2010/main">
-        <mc:Choice Requires="a14">
+      <mc:AlternateContent xmlns:mc="http://schemas.openxmlformats.org/markup-compatibility/2006">
+        <mc:Choice xmlns:a14="http://schemas.microsoft.com/office/drawing/2010/main" Requires="a14">
           <p:sp>
             <p:nvSpPr>
               <p:cNvPr id="3" name="Content Placeholder 2"/>
@@ -7305,8 +7305,13 @@
                 </a14:m>
                 <a:r>
                   <a:rPr lang="en-US" dirty="0"/>
-                  <a:t> quantiles of a distribution</a:t>
+                  <a:t> quantiles of </a:t>
                 </a:r>
+                <a:r>
+                  <a:rPr lang="en-US"/>
+                  <a:t>a sampling distribution</a:t>
+                </a:r>
+                <a:endParaRPr lang="en-US" dirty="0"/>
               </a:p>
               <a:p>
                 <a:pPr lvl="0"/>
@@ -7771,7 +7776,7 @@
             </p:txBody>
           </p:sp>
         </mc:Choice>
-        <mc:Fallback xmlns="">
+        <mc:Fallback>
           <p:sp>
             <p:nvSpPr>
               <p:cNvPr id="3" name="Content Placeholder 2"/>

</xml_diff>